<commit_message>
Updated docx and ppt
</commit_message>
<xml_diff>
--- a/Documentation/SplitSync_Presentation.pptx
+++ b/Documentation/SplitSync_Presentation.pptx
@@ -3825,16 +3825,7 @@
                 </a:solidFill>
                 <a:latin typeface="Arial"/>
               </a:rPr>
-              <a:t>•  </a:t>
-            </a:r>
-            <a:r>
-              <a:rPr sz="1700">
-                <a:solidFill>
-                  <a:srgbClr val="57657A"/>
-                </a:solidFill>
-                <a:latin typeface="Arial"/>
-              </a:rPr>
-              <a:t>Integration tests in server.Tests, in-memory database</a:t>
+              <a:t>•  Integration tests in server.Tests, in-memory database</a:t>
             </a:r>
           </a:p>
           <a:p>
@@ -3853,16 +3844,7 @@
                 </a:solidFill>
                 <a:latin typeface="Arial"/>
               </a:rPr>
-              <a:t>•  </a:t>
-            </a:r>
-            <a:r>
-              <a:rPr sz="1700">
-                <a:solidFill>
-                  <a:srgbClr val="57657A"/>
-                </a:solidFill>
-                <a:latin typeface="Arial"/>
-              </a:rPr>
-              <a:t>Covers auth, groups, expenses (incl. split maths), settlements, receipts, health endpoint</a:t>
+              <a:t>•  Covers auth, groups, expenses (incl. split maths and edit/delete access checks), settlements, receipts, health endpoint</a:t>
             </a:r>
           </a:p>
           <a:p>
@@ -3881,16 +3863,7 @@
                 </a:solidFill>
                 <a:latin typeface="Arial"/>
               </a:rPr>
-              <a:t>•  </a:t>
-            </a:r>
-            <a:r>
-              <a:rPr sz="1700">
-                <a:solidFill>
-                  <a:srgbClr val="57657A"/>
-                </a:solidFill>
-                <a:latin typeface="Arial"/>
-              </a:rPr>
-              <a:t>49 tests, all passing as of 24 Sept</a:t>
+              <a:t>•  61 tests, all passing as of 6 Oct</a:t>
             </a:r>
           </a:p>
         </p:txBody>
@@ -3971,16 +3944,7 @@
                 </a:solidFill>
                 <a:latin typeface="Arial"/>
               </a:rPr>
-              <a:t>•  </a:t>
-            </a:r>
-            <a:r>
-              <a:rPr sz="1700">
-                <a:solidFill>
-                  <a:srgbClr val="57657A"/>
-                </a:solidFill>
-                <a:latin typeface="Arial"/>
-              </a:rPr>
-              <a:t>Test cases for auth, groups, expenses, settlements, recurring expenses, activity, settings</a:t>
+              <a:t>•  Test cases for auth, groups, expenses, settlements, recurring expenses, activity, settings, all passing</a:t>
             </a:r>
           </a:p>
           <a:p>
@@ -3999,16 +3963,7 @@
                 </a:solidFill>
                 <a:latin typeface="Arial"/>
               </a:rPr>
-              <a:t>•  </a:t>
-            </a:r>
-            <a:r>
-              <a:rPr sz="1700">
-                <a:solidFill>
-                  <a:srgbClr val="57657A"/>
-                </a:solidFill>
-                <a:latin typeface="Arial"/>
-              </a:rPr>
-              <a:t>Documentation/Test Cases</a:t>
+              <a:t>•  Documentation/Test Cases</a:t>
             </a:r>
           </a:p>
           <a:p>
@@ -4027,79 +3982,7 @@
                 </a:solidFill>
                 <a:latin typeface="Arial"/>
               </a:rPr>
-              <a:t>•  </a:t>
-            </a:r>
-            <a:r>
-              <a:rPr sz="1700">
-                <a:solidFill>
-                  <a:srgbClr val="57657A"/>
-                </a:solidFill>
-                <a:latin typeface="Arial"/>
-              </a:rPr>
-              <a:t>Cypress e2e test for the authentication page</a:t>
-            </a:r>
-          </a:p>
-        </p:txBody>
-      </p:sp>
-      <p:sp>
-        <p:nvSpPr>
-          <p:cNvPr id="10" name="Rounded Rectangle 9"/>
-          <p:cNvSpPr/>
-          <p:nvPr/>
-        </p:nvSpPr>
-        <p:spPr>
-          <a:xfrm>
-            <a:off x="548640" y="5120640"/>
-            <a:ext cx="11091672" cy="868680"/>
-          </a:xfrm>
-          <a:prstGeom prst="roundRect">
-            <a:avLst>
-              <a:gd name="adj" fmla="val 12000"/>
-            </a:avLst>
-          </a:prstGeom>
-          <a:solidFill>
-            <a:srgbClr val="FBEFE4"/>
-          </a:solidFill>
-          <a:ln>
-            <a:noFill/>
-          </a:ln>
-        </p:spPr>
-        <p:style>
-          <a:lnRef idx="1">
-            <a:schemeClr val="accent1"/>
-          </a:lnRef>
-          <a:fillRef idx="3">
-            <a:schemeClr val="accent1"/>
-          </a:fillRef>
-          <a:effectRef idx="2">
-            <a:schemeClr val="accent1"/>
-          </a:effectRef>
-          <a:fontRef idx="minor">
-            <a:schemeClr val="lt1"/>
-          </a:fontRef>
-        </p:style>
-        <p:txBody>
-          <a:bodyPr wrap="square" lIns="228600" tIns="109728" rtlCol="0" anchor="ctr"/>
-          <a:lstStyle/>
-          <a:p>
-            <a:pPr algn="ctr"/>
-            <a:r>
-              <a:rPr sz="1400" b="1">
-                <a:solidFill>
-                  <a:srgbClr val="B45A09"/>
-                </a:solidFill>
-                <a:latin typeface="Arial"/>
-              </a:rPr>
-              <a:t>Gap:  </a:t>
-            </a:r>
-            <a:r>
-              <a:rPr sz="1400">
-                <a:solidFill>
-                  <a:srgbClr val="0B1220"/>
-                </a:solidFill>
-                <a:latin typeface="Arial"/>
-              </a:rPr>
-              <a:t>no Cypress tests yet for the newer features like editing expenses, receipts and the group dashboard.</a:t>
+              <a:t>•  Cypress e2e tests: auth, profile, groups, group dashboard, expenses (add/edit/delete + access checks), receipts, notifications</a:t>
             </a:r>
           </a:p>
         </p:txBody>
@@ -4498,34 +4381,6 @@
               <a:t>Only one receipt photo per expense.</a:t>
             </a:r>
           </a:p>
-          <a:p>
-            <a:pPr>
-              <a:lnSpc>
-                <a:spcPct val="105000"/>
-              </a:lnSpc>
-              <a:spcAft>
-                <a:spcPts val="2200"/>
-              </a:spcAft>
-            </a:pPr>
-            <a:r>
-              <a:rPr sz="1900" b="1">
-                <a:solidFill>
-                  <a:srgbClr val="B45A09"/>
-                </a:solidFill>
-                <a:latin typeface="Arial"/>
-              </a:rPr>
-              <a:t>•  </a:t>
-            </a:r>
-            <a:r>
-              <a:rPr sz="1900">
-                <a:solidFill>
-                  <a:srgbClr val="57657A"/>
-                </a:solidFill>
-                <a:latin typeface="Arial"/>
-              </a:rPr>
-              <a:t>Not much frontend test coverage yet on the newer features.</a:t>
-            </a:r>
-          </a:p>
         </p:txBody>
       </p:sp>
       <p:sp>
@@ -8776,6 +8631,22 @@
               <a:t>Light / dark theme</a:t>
             </a:r>
           </a:p>
+          <a:p>
+            <a:pPr>
+              <a:spcBef>
+                <a:spcPts val="400"/>
+              </a:spcBef>
+            </a:pPr>
+            <a:r>
+              <a:rPr sz="1250">
+                <a:solidFill>
+                  <a:srgbClr val="0B1220"/>
+                </a:solidFill>
+                <a:latin typeface="Arial"/>
+              </a:rPr>
+              <a:t>Key deps: React 19, React Router 7, Tailwind CSS 4, Cypress (e2e tests)</a:t>
+            </a:r>
+          </a:p>
         </p:txBody>
       </p:sp>
       <p:sp>
@@ -8896,6 +8767,22 @@
               <a:t>[Authorize] on every route but auth</a:t>
             </a:r>
           </a:p>
+          <a:p>
+            <a:pPr>
+              <a:spcBef>
+                <a:spcPts val="400"/>
+              </a:spcBef>
+            </a:pPr>
+            <a:r>
+              <a:rPr sz="1250">
+                <a:solidFill>
+                  <a:srgbClr val="0B1220"/>
+                </a:solidFill>
+                <a:latin typeface="Arial"/>
+              </a:rPr>
+              <a:t>Key deps: EF Core 10, JWT Bearer, xUnit (integration tests)</a:t>
+            </a:r>
+          </a:p>
         </p:txBody>
       </p:sp>
       <p:sp>
@@ -9014,6 +8901,22 @@
                 <a:latin typeface="Arial"/>
               </a:rPr>
               <a:t>behind an IReceiptStorage interface</a:t>
+            </a:r>
+          </a:p>
+          <a:p>
+            <a:pPr>
+              <a:spcBef>
+                <a:spcPts val="400"/>
+              </a:spcBef>
+            </a:pPr>
+            <a:r>
+              <a:rPr sz="1250">
+                <a:solidFill>
+                  <a:srgbClr val="0B1220"/>
+                </a:solidFill>
+                <a:latin typeface="Arial"/>
+              </a:rPr>
+              <a:t>Key deps: Npgsql.EntityFrameworkCore.PostgreSQL</a:t>
             </a:r>
           </a:p>
         </p:txBody>

</xml_diff>